<commit_message>
fix(sesi-01): update all 18 slide hyperlink buttons in pptx to direct html files
</commit_message>
<xml_diff>
--- a/slide_presentasi/SESI_01_Pengantar_dan_Lingkungan_Ionic.pptx
+++ b/slide_presentasi/SESI_01_Pengantar_dan_Lingkungan_Ionic.pptx
@@ -3244,8 +3244,8 @@
         </p:nvSpPr>
         <p:spPr>
           <a:xfrm>
-            <a:off x="1280160" y="1188720"/>
-            <a:ext cx="9601200" cy="4389120"/>
+            <a:off x="1280160" y="1097280"/>
+            <a:ext cx="9601200" cy="3931920"/>
           </a:xfrm>
           <a:prstGeom prst="rect">
             <a:avLst/>
@@ -3260,7 +3260,7 @@
           <a:p>
             <a:pPr>
               <a:spcAft>
-                <a:spcPts val="1600"/>
+                <a:spcPts val="1200"/>
               </a:spcAft>
               <a:defRPr sz="1200" b="1">
                 <a:solidFill>
@@ -3276,9 +3276,9 @@
           <a:p>
             <a:pPr>
               <a:spcAft>
-                <a:spcPts val="1400"/>
+                <a:spcPts val="1000"/>
               </a:spcAft>
-              <a:defRPr sz="2800" b="1">
+              <a:defRPr sz="2600" b="1">
                 <a:solidFill>
                   <a:srgbClr val="000000"/>
                 </a:solidFill>
@@ -3296,9 +3296,9 @@
           <a:p>
             <a:pPr>
               <a:spcAft>
-                <a:spcPts val="3600"/>
+                <a:spcPts val="2200"/>
               </a:spcAft>
-              <a:defRPr sz="1400">
+              <a:defRPr sz="1300">
                 <a:solidFill>
                   <a:srgbClr val="3C3C3C"/>
                 </a:solidFill>
@@ -3311,7 +3311,7 @@
           </a:p>
           <a:p>
             <a:pPr>
-              <a:defRPr sz="1150" b="1">
+              <a:defRPr sz="1100" b="1">
                 <a:solidFill>
                   <a:srgbClr val="000000"/>
                 </a:solidFill>
@@ -3320,6 +3320,142 @@
             </a:pPr>
             <a:r>
               <a:t>■  Anton Prafanto, S.Kom., M.T. • Program Studi S1 Sistem Informasi / Informatika  ■  FAKULTAS SAINS DAN TEKNOLOGI • UNIVERSITAS TERBUKA</a:t>
+            </a:r>
+          </a:p>
+        </p:txBody>
+      </p:sp>
+      <p:sp>
+        <p:nvSpPr>
+          <p:cNvPr id="6" name="Rectangle 5"/>
+          <p:cNvSpPr/>
+          <p:nvPr/>
+        </p:nvSpPr>
+        <p:spPr>
+          <a:xfrm>
+            <a:off x="1316736" y="5111496"/>
+            <a:ext cx="9601200" cy="621792"/>
+          </a:xfrm>
+          <a:prstGeom prst="rect">
+            <a:avLst/>
+          </a:prstGeom>
+          <a:solidFill>
+            <a:srgbClr val="000000"/>
+          </a:solidFill>
+          <a:ln>
+            <a:noFill/>
+          </a:ln>
+        </p:spPr>
+        <p:style>
+          <a:lnRef idx="1">
+            <a:schemeClr val="accent1"/>
+          </a:lnRef>
+          <a:fillRef idx="3">
+            <a:schemeClr val="accent1"/>
+          </a:fillRef>
+          <a:effectRef idx="2">
+            <a:schemeClr val="accent1"/>
+          </a:effectRef>
+          <a:fontRef idx="minor">
+            <a:schemeClr val="lt1"/>
+          </a:fontRef>
+        </p:style>
+        <p:txBody>
+          <a:bodyPr rtlCol="0" anchor="ctr"/>
+          <a:lstStyle/>
+          <a:p>
+            <a:pPr algn="ctr"/>
+          </a:p>
+        </p:txBody>
+      </p:sp>
+      <p:sp>
+        <p:nvSpPr>
+          <p:cNvPr id="7" name="Rectangle 6"/>
+          <p:cNvSpPr/>
+          <p:nvPr/>
+        </p:nvSpPr>
+        <p:spPr>
+          <a:xfrm>
+            <a:off x="1280160" y="5074920"/>
+            <a:ext cx="9601200" cy="621792"/>
+          </a:xfrm>
+          <a:prstGeom prst="rect">
+            <a:avLst/>
+          </a:prstGeom>
+          <a:solidFill>
+            <a:srgbClr val="FFE600"/>
+          </a:solidFill>
+          <a:ln w="25400">
+            <a:solidFill>
+              <a:srgbClr val="000000"/>
+            </a:solidFill>
+          </a:ln>
+        </p:spPr>
+        <p:style>
+          <a:lnRef idx="1">
+            <a:schemeClr val="accent1"/>
+          </a:lnRef>
+          <a:fillRef idx="3">
+            <a:schemeClr val="accent1"/>
+          </a:fillRef>
+          <a:effectRef idx="2">
+            <a:schemeClr val="accent1"/>
+          </a:effectRef>
+          <a:fontRef idx="minor">
+            <a:schemeClr val="lt1"/>
+          </a:fontRef>
+        </p:style>
+        <p:txBody>
+          <a:bodyPr rtlCol="0" anchor="ctr"/>
+          <a:lstStyle/>
+          <a:p>
+            <a:pPr algn="ctr"/>
+          </a:p>
+        </p:txBody>
+      </p:sp>
+      <p:sp>
+        <p:nvSpPr>
+          <p:cNvPr id="8" name="TextBox 7"/>
+          <p:cNvSpPr txBox="1"/>
+          <p:nvPr/>
+        </p:nvSpPr>
+        <p:spPr>
+          <a:xfrm>
+            <a:off x="1371600" y="5111496"/>
+            <a:ext cx="9418320" cy="548640"/>
+          </a:xfrm>
+          <a:prstGeom prst="rect">
+            <a:avLst/>
+          </a:prstGeom>
+          <a:noFill/>
+        </p:spPr>
+        <p:txBody>
+          <a:bodyPr wrap="square">
+            <a:spAutoFit/>
+          </a:bodyPr>
+          <a:lstStyle/>
+          <a:p>
+            <a:r>
+              <a:rPr sz="1000" b="1">
+                <a:solidFill>
+                  <a:srgbClr val="000000"/>
+                </a:solidFill>
+                <a:latin typeface="Segoe UI"/>
+                <a:hlinkClick r:id="rId2"/>
+              </a:rPr>
+              <a:t>▶ BUKA KONTRAK KULIAH, ROADMAP 8 SESI &amp; KALKULATOR NILAI (slide_01_kontrak_dan_roadmap.html)</a:t>
+            </a:r>
+          </a:p>
+          <a:p>
+            <a:pPr>
+              <a:defRPr sz="800">
+                <a:solidFill>
+                  <a:srgbClr val="3C3C3C"/>
+                </a:solidFill>
+                <a:latin typeface="Segoe UI"/>
+              </a:defRPr>
+            </a:pPr>
+            <a:r>
+              <a:t>💡 Klik ganda berkas HTML untuk simulasi nilai 50% Tuton + 50% UAS interaktif</a:t>
             </a:r>
           </a:p>
         </p:txBody>
@@ -4736,7 +4872,7 @@
               </a:defRPr>
             </a:pPr>
             <a:r>
-              <a:t>slide_11_ionic_cli_simulator.js  |  KODE IMPLEMENTASI</a:t>
+              <a:t>slide_11_ionic_cli_simulator.html  |  KODE IMPLEMENTASI</a:t>
             </a:r>
           </a:p>
         </p:txBody>
@@ -4922,7 +5058,7 @@
                 <a:latin typeface="Segoe UI"/>
                 <a:hlinkClick r:id="rId2"/>
               </a:rPr>
-              <a:t>▶ BUKA KODE LENGKAP DI GITHUB (slide_11_ionic_cli_simulator.js)</a:t>
+              <a:t>▶ BUKA KODE LENGKAP DI GITHUB (slide_11_ionic_cli_simulator.html)</a:t>
             </a:r>
           </a:p>
           <a:p>
@@ -5545,7 +5681,7 @@
               </a:defRPr>
             </a:pPr>
             <a:r>
-              <a:t>slide_12_struktur_folder_proyek.js  |  KODE IMPLEMENTASI</a:t>
+              <a:t>slide_12_struktur_folder_proyek.html  |  KODE IMPLEMENTASI</a:t>
             </a:r>
           </a:p>
         </p:txBody>
@@ -5732,7 +5868,7 @@
                 <a:latin typeface="Segoe UI"/>
                 <a:hlinkClick r:id="rId2"/>
               </a:rPr>
-              <a:t>▶ BUKA KODE LENGKAP DI GITHUB (slide_12_struktur_folder_proyek.js)</a:t>
+              <a:t>▶ BUKA KODE LENGKAP DI GITHUB (slide_12_struktur_folder_proyek.html)</a:t>
             </a:r>
           </a:p>
           <a:p>
@@ -6355,7 +6491,7 @@
               </a:defRPr>
             </a:pPr>
             <a:r>
-              <a:t>slide_13_usb_debugging_scrcpy_guide.md  |  KODE IMPLEMENTASI</a:t>
+              <a:t>slide_13_usb_debugging_scrcpy_guide.html  |  KODE IMPLEMENTASI</a:t>
             </a:r>
           </a:p>
         </p:txBody>
@@ -6543,7 +6679,7 @@
                 <a:latin typeface="Segoe UI"/>
                 <a:hlinkClick r:id="rId2"/>
               </a:rPr>
-              <a:t>▶ BUKA KODE LENGKAP DI GITHUB (slide_13_usb_debugging_scrcpy_guide.md)</a:t>
+              <a:t>▶ BUKA KODE LENGKAP DI GITHUB (slide_13_usb_debugging_scrcpy_guide.html)</a:t>
             </a:r>
           </a:p>
           <a:p>
@@ -7969,7 +8105,7 @@
               </a:defRPr>
             </a:pPr>
             <a:r>
-              <a:t>slide_15_troubleshooting_powershell_cli.md  |  KODE IMPLEMENTASI</a:t>
+              <a:t>slide_15_troubleshooting_powershell_cli.html  |  KODE IMPLEMENTASI</a:t>
             </a:r>
           </a:p>
         </p:txBody>
@@ -8150,7 +8286,7 @@
                 <a:latin typeface="Segoe UI"/>
                 <a:hlinkClick r:id="rId2"/>
               </a:rPr>
-              <a:t>▶ BUKA KODE LENGKAP DI GITHUB (slide_15_troubleshooting_powershell_cli.md)</a:t>
+              <a:t>▶ BUKA KODE LENGKAP DI GITHUB (slide_15_troubleshooting_powershell_cli.html)</a:t>
             </a:r>
           </a:p>
           <a:p>
@@ -8773,7 +8909,7 @@
               </a:defRPr>
             </a:pPr>
             <a:r>
-              <a:t>slide_16_cheatsheet_terminal_git.md  |  KODE IMPLEMENTASI</a:t>
+              <a:t>slide_16_cheatsheet_terminal_git.html  |  KODE IMPLEMENTASI</a:t>
             </a:r>
           </a:p>
         </p:txBody>
@@ -8953,7 +9089,7 @@
                 <a:latin typeface="Segoe UI"/>
                 <a:hlinkClick r:id="rId2"/>
               </a:rPr>
-              <a:t>▶ BUKA KODE LENGKAP DI GITHUB (slide_16_cheatsheet_terminal_git.md)</a:t>
+              <a:t>▶ BUKA KODE LENGKAP DI GITHUB (slide_16_cheatsheet_terminal_git.html)</a:t>
             </a:r>
           </a:p>
           <a:p>
@@ -13746,7 +13882,7 @@
               </a:defRPr>
             </a:pPr>
             <a:r>
-              <a:t>slide_05_panduan_instalasi_tools.js  |  KODE IMPLEMENTASI</a:t>
+              <a:t>slide_05_panduan_instalasi_tools.html  |  KODE IMPLEMENTASI</a:t>
             </a:r>
           </a:p>
         </p:txBody>
@@ -13939,7 +14075,7 @@
                 <a:latin typeface="Segoe UI"/>
                 <a:hlinkClick r:id="rId2"/>
               </a:rPr>
-              <a:t>▶ BUKA KODE LENGKAP DI GITHUB (slide_05_panduan_instalasi_tools.js)</a:t>
+              <a:t>▶ BUKA KODE LENGKAP DI GITHUB (slide_05_panduan_instalasi_tools.html)</a:t>
             </a:r>
           </a:p>
           <a:p>
@@ -14393,7 +14529,7 @@
               </a:defRPr>
             </a:pPr>
             <a:r>
-              <a:t>💡 Tips Praktis: Jalankan skrip ini sebelum memulai praktikum untuk memastikan tidak ada tools yang kurang.</a:t>
+              <a:t>💡 Tips Praktis: Buka berkas HTML di browser atau jalankan via terminal untuk memastikan kesiapan laptop.</a:t>
             </a:r>
           </a:p>
         </p:txBody>
@@ -14562,7 +14698,7 @@
               </a:defRPr>
             </a:pPr>
             <a:r>
-              <a:t>slide_06_diagnostik_environment.js  |  KODE IMPLEMENTASI</a:t>
+              <a:t>slide_06_diagnostik_environment.html  |  KODE IMPLEMENTASI</a:t>
             </a:r>
           </a:p>
         </p:txBody>
@@ -14764,7 +14900,7 @@
                 <a:latin typeface="Segoe UI"/>
                 <a:hlinkClick r:id="rId2"/>
               </a:rPr>
-              <a:t>▶ BUKA KODE LENGKAP DI GITHUB (slide_06_diagnostik_environment.js)</a:t>
+              <a:t>▶ BUKA KODE LENGKAP DI GITHUB (slide_06_diagnostik_environment.html)</a:t>
             </a:r>
           </a:p>
           <a:p>

</xml_diff>